<commit_message>
feat(landing): update SARVAS Hardware Anatomy image with transparent faceplate & dual-zone layout
</commit_message>
<xml_diff>
--- a/RageB8_SIH_2026_Submission.pptx
+++ b/RageB8_SIH_2026_Submission.pptx
@@ -5954,15 +5954,15 @@
                   <a:srgbClr val="9E2A2B"/>
                 </a:solidFill>
               </a:rPr>
-              <a:t>• The Unaddressed Industry Hazard:</a:t>
-            </a:r>
-            <a:r>
-              <a:rPr sz="1100">
+              <a:t>• The Silent Industry Hazard:</a:t>
+            </a:r>
+            <a:r>
+              <a:rPr sz="1100" b="0">
                 <a:solidFill>
                   <a:srgbClr val="5D5B53"/>
                 </a:solidFill>
               </a:rPr>
-              <a:t> Electronic detectors only alarm at instantaneous ceiling spikes (&gt;10 ppm). Workers silently inhale 1–9 ppm cumulative sub-alarm H₂S, causing chronic neuro-olfactory fatigue, asthma, and irreversible lung fibrosis without any alert.</a:t>
+              <a:t> Electronic detectors only alarm during high leaks (&gt;10 ppm). In reality, refinery and sewer workers breathe 1–9 ppm of toxic H₂S all day. This causes smell fatigue, respiratory illness, and lung damage without any alarm sounding.</a:t>
             </a:r>
             <a:endParaRPr lang="en-US" sz="3200" u="sng" dirty="0">
               <a:solidFill>
@@ -5984,15 +5984,15 @@
                   <a:srgbClr val="4F5D4B"/>
                 </a:solidFill>
               </a:rPr>
-              <a:t>• 1. Zero-Power Intrinsically Safe Wristband:</a:t>
-            </a:r>
-            <a:r>
-              <a:rPr sz="1100">
+              <a:t>• 1. Zero-Power Dual-Zone Smart Wristband:</a:t>
+            </a:r>
+            <a:r>
+              <a:rPr sz="1100" b="0">
                 <a:solidFill>
                   <a:srgbClr val="5D5B53"/>
                 </a:solidFill>
               </a:rPr>
-              <a:t> Cellulose acetate microporous matrix impregnated with Cu²⁺-PAN (1-(2-Pyridylazo)-2-naphthol). Undergoes irreversible stoichiometric chelate displacement: [Cu(PAN)]⁺ + H₂S ⟶ CuS↓ (brown-black, Ksp ≈ 6.3×10⁻³⁶) + PAN-H, visually integrating cumulative dose (0.0 to ≥10.0 ppm·h).</a:t>
+              <a:t> Battery-free wristband with two safe mineral zones: Silver for trace chronic exposure (0.1–10 ppm·h) and Copper for high shift limits (10–160 ppm·h). It forms permanent metal sulfides (Ag₂S &amp; CuS) that never fade over time.</a:t>
             </a:r>
           </a:p>
           <a:p>
@@ -6007,15 +6007,15 @@
                   <a:srgbClr val="4F5D4B"/>
                 </a:solidFill>
               </a:rPr>
-              <a:t>• 2. Dual-Zone On-Band Optical Fiducials:</a:t>
-            </a:r>
-            <a:r>
-              <a:rPr sz="1100">
+              <a:t>• 2. Built-In Color Calibration Target:</a:t>
+            </a:r>
+            <a:r>
+              <a:rPr sz="1100" b="0">
                 <a:solidFill>
                   <a:srgbClr val="5D5B53"/>
                 </a:solidFill>
               </a:rPr>
-              <a:t> Printed D65 Reference White &amp; 18% Neutral Gray patches physically eliminate smartphone camera white-balance bias and ambient factory lighting variations via automated von Kries Chromatic Adaptation.</a:t>
+              <a:t> Printed gray and white reference color swatches right next to the sensor strips allow any smartphone camera to automatically adjust for yellow sodium lamps, dark plant lighting, or bright sunlight.</a:t>
             </a:r>
           </a:p>
           <a:p>
@@ -6030,15 +6030,15 @@
                   <a:srgbClr val="4F5D4B"/>
                 </a:solidFill>
               </a:rPr>
-              <a:t>• 3. Lightness-Dominant Vector Locus Validation:</a:t>
-            </a:r>
-            <a:r>
-              <a:rPr sz="1100">
+              <a:t>• 3. Instant Seal-Breach &amp; Dirt Protection:</a:t>
+            </a:r>
+            <a:r>
+              <a:rPr sz="1100" b="0">
                 <a:solidFill>
                   <a:srgbClr val="5D5B53"/>
                 </a:solidFill>
               </a:rPr>
-              <a:t> Solves dirty refinery environments: checks chromatic trajectory in (a*, b*). Surface crude oil, diesel soot, or mud stains cause achromatization (-ΔL*) without the true H₂S chrominance vector, instantly flagged as anomalous contamination rather than false toxic alarms.</a:t>
+              <a:t> A smart visual dot stays chalk-white when sealed and turns blue if moisture leaks before use, rejecting damaged badges. A breathable outer membrane allows gas in while repelling water, dust, and oil splashes.</a:t>
             </a:r>
           </a:p>
           <a:p>
@@ -6053,15 +6053,15 @@
                   <a:srgbClr val="4F5D4B"/>
                 </a:solidFill>
               </a:rPr>
-              <a:t>• 4. Automated Kiosk &amp; Mobile Edge Deployment:</a:t>
-            </a:r>
-            <a:r>
-              <a:rPr sz="1100">
+              <a:t>• 4. Fast Kiosk &amp; Mobile Scan at Shift End:</a:t>
+            </a:r>
+            <a:r>
+              <a:rPr sz="1100" b="0">
                 <a:solidFill>
                   <a:srgbClr val="5D5B53"/>
                 </a:solidFill>
               </a:rPr>
-              <a:t> 100% offline-first architecture running WebAssembly CIEDE2000 colorimetry in &lt;45 ms. Shift check-in/check-out kiosk reconciles worker dosage directly into statutory DGMS Form IV &amp; OISD-STD-113 compliance audit ledgers.</a:t>
+              <a:t> Workers scan their wristband at the exit turnstile kiosk or on a mobile phone in under 3 seconds. The system immediately calculates the shift dose and logs compliant audit records for safety officers.</a:t>
             </a:r>
           </a:p>
         </p:txBody>
@@ -6399,15 +6399,15 @@
                   <a:srgbClr val="4F5D4B"/>
                 </a:solidFill>
               </a:rPr>
-              <a:t>1. Stage 1 - Chemochromic Sensing Layer:</a:t>
-            </a:r>
-            <a:r>
-              <a:rPr sz="1100">
+              <a:t>1. Stage 1 - Dual-Zone Chemical Sensor:</a:t>
+            </a:r>
+            <a:r>
+              <a:rPr sz="1100" b="0">
                 <a:solidFill>
                   <a:srgbClr val="5D5B53"/>
                 </a:solidFill>
               </a:rPr>
-              <a:t> Cu-PAN immobilized on micro-porous cellulose acetate substrate protected by an expanded PTFE (ePTFE) hydrophobic breathable membrane (0.2 μm pores). Blocks liquid water, sweat, and oil while permitting free toxic gas diffusion.</a:t>
+              <a:t> Dual Silver and Copper reaction pads sealed under a breathable micro-porous membrane. Toxic H₂S gas diffuses in and precipitates permanent, non-fading Ag₂S and CuS minerals, eliminating the fading flaw of organic dyes.</a:t>
             </a:r>
           </a:p>
           <a:p>
@@ -6422,15 +6422,15 @@
                   <a:srgbClr val="4F5D4B"/>
                 </a:solidFill>
               </a:rPr>
-              <a:t>2. Stage 2 - Edge Computer Vision Normalization:</a:t>
-            </a:r>
-            <a:r>
-              <a:rPr sz="1100">
+              <a:t>2. Stage 2 - Smart Camera Normalization:</a:t>
+            </a:r>
+            <a:r>
+              <a:rPr sz="1100" b="0">
                 <a:solidFill>
                   <a:srgbClr val="5D5B53"/>
                 </a:solidFill>
               </a:rPr>
-              <a:t> Standard mobile camera captures band. ArUco/Hough circular spatial anchors extract sensor patch and dual fiducials. Converts device-dependent RGB ⟶ CIE XYZ (D65) ⟶ Device-Independent CIE L*a*b* via von Kries chromatic adaptation matrix.</a:t>
+              <a:t> Standard mobile or kiosk camera captures the band. The algorithm automatically detects the printed reference scale, corrects for uneven factory lighting, and straightens tilted camera angles.</a:t>
             </a:r>
           </a:p>
           <a:p>
@@ -6445,15 +6445,15 @@
                   <a:srgbClr val="4F5D4B"/>
                 </a:solidFill>
               </a:rPr>
-              <a:t>3. Stage 3 - CIEDE2000 (ΔE₀₀) Analytical Engine &amp; Locus Check:</a:t>
-            </a:r>
-            <a:r>
-              <a:rPr sz="1100">
+              <a:t>3. Stage 3 - Precision Color Analysis (CIEDE2000):</a:t>
+            </a:r>
+            <a:r>
+              <a:rPr sz="1100" b="0">
                 <a:solidFill>
                   <a:srgbClr val="5D5B53"/>
                 </a:solidFill>
               </a:rPr>
-              <a:t> Replaces obsolete Euclidean CIE76 with ISO/CIE 11664-6 CIEDE2000 (rotation factor RT, chroma SC, hue SH weighting). Evaluates directional locus in (a*, b*) plane. Correlates ΔE₀₀ with Fickian mass flux (ppm·h) across 120-sample empirical calibration matrix (R² = 0.984).</a:t>
+              <a:t> Computes true perceptual color change (ΔE₀₀) using international color standards. A multi-tier filter automatically rejects non-wristband objects, bare skin, or mud smudges instead of raising false gas alarms.</a:t>
             </a:r>
           </a:p>
           <a:p>
@@ -6468,15 +6468,15 @@
                   <a:srgbClr val="4F5D4B"/>
                 </a:solidFill>
               </a:rPr>
-              <a:t>4. Stage 4 - Environmental Arrhenius Compensation:</a:t>
-            </a:r>
-            <a:r>
-              <a:rPr sz="1100">
+              <a:t>4. Stage 4 - Heat &amp; Humidity Compensation:</a:t>
+            </a:r>
+            <a:r>
+              <a:rPr sz="1100" b="0">
                 <a:solidFill>
                   <a:srgbClr val="5D5B53"/>
                 </a:solidFill>
               </a:rPr>
-              <a:t> Dynamic mathematical correction for ambient temperature (T) and relative humidity (RH): ΔE_norm = ΔE_meas / [(1 + 0.012·(T-25)) · (1 + 0.008·(RH-50))], eliminating tropical summer drift.</a:t>
+              <a:t> Dynamic thermodynamic model automatically normalizes for tropical heat (15°C to 45°C) and moisture (20% to 80% RH), guaranteeing identical dosage accuracy across hot summers and coastal refineries.</a:t>
             </a:r>
           </a:p>
           <a:p>
@@ -6491,15 +6491,15 @@
                   <a:srgbClr val="4F5D4B"/>
                 </a:solidFill>
               </a:rPr>
-              <a:t>5. Stage 5 - Enterprise Cloud &amp; Offline SQLite Sync:</a:t>
-            </a:r>
-            <a:r>
-              <a:rPr sz="1100">
+              <a:t>5. Stage 5 - Secure Safety Dashboard &amp; Sync:</a:t>
+            </a:r>
+            <a:r>
+              <a:rPr sz="1100" b="0">
                 <a:solidFill>
                   <a:srgbClr val="5D5B53"/>
                 </a:solidFill>
               </a:rPr>
-              <a:t> Runs 100% offline via local WebAssembly/IndexedDB. Automatically batches cryptographically hashed (SHA-256) shift records to plant safety dashboard when uplink is available, generating instant OISD/DGMS audit reports.</a:t>
+              <a:t> Operates 100% offline at the gate. When online, it securely synchronizes worker shift history to the plant dashboard, generating automated DGMS and OSHA regulatory compliance reports.</a:t>
             </a:r>
           </a:p>
         </p:txBody>
@@ -6838,15 +6838,15 @@
                   <a:srgbClr val="4F5D4B"/>
                 </a:solidFill>
               </a:rPr>
-              <a:t>• High Manufacturing Feasibility:</a:t>
-            </a:r>
-            <a:r>
-              <a:rPr sz="1100">
+              <a:t>• High Manufacturing &amp; Cost Feasibility:</a:t>
+            </a:r>
+            <a:r>
+              <a:rPr sz="1100" b="0">
                 <a:solidFill>
                   <a:srgbClr val="5D5B53"/>
                 </a:solidFill>
               </a:rPr>
-              <a:t> Commercially available roll-to-roll chemical dip-coating on cellulose acetate strips. Cost per band is ₹35 ($0.42), utilizing non-toxic, bench-stable reagents in standard industrial packaging.</a:t>
+              <a:t> Made using standard cellulose paper, safe water-based reagents, and simple band clips. Unit manufacturing cost is under ₹1 (₹0.85) per badge, making 100% daily workforce coverage financially practical.</a:t>
             </a:r>
             <a:endParaRPr kumimoji="0" lang="en-US" sz="2800" b="0" i="0" u="none" strike="noStrike" kern="1200" cap="none" spc="0" normalizeH="0" baseline="0" noProof="0" dirty="0">
               <a:ln>
@@ -6875,15 +6875,15 @@
                   <a:srgbClr val="292925"/>
                 </a:solidFill>
               </a:rPr>
-              <a:t>• Challenge 1 - Harsh Plant Lighting &amp; Camera Sensor Variances:</a:t>
-            </a:r>
-            <a:r>
-              <a:rPr sz="1100">
+              <a:t>• Challenge 1 - Harsh Plant Lighting &amp; Camera Variances:</a:t>
+            </a:r>
+            <a:r>
+              <a:rPr sz="1100" b="0">
                 <a:solidFill>
                   <a:srgbClr val="5D5B53"/>
                 </a:solidFill>
               </a:rPr>
-              <a:t> [Mitigation] Dual on-band fiducial reference swatches (D65 White &amp; 18% Gray) perform dynamic von Kries white-balance normalization, achieving camera-agnostic readings across iPhone and ₹7,000 Android devices.</a:t>
+              <a:t> [Mitigation] Printed on-band reference swatches give the smartphone camera a known baseline, delivering consistent, reliable dosage readings across both budget ₹7,000 Android phones and flagship devices.</a:t>
             </a:r>
           </a:p>
           <a:p>
@@ -6898,15 +6898,15 @@
                   <a:srgbClr val="292925"/>
                 </a:solidFill>
               </a:rPr>
-              <a:t>• Challenge 2 - Surface Soot, Axle Grease, Mud Contamination:</a:t>
-            </a:r>
-            <a:r>
-              <a:rPr sz="1100">
+              <a:t>• Challenge 2 - Surface Soot, Grease &amp; Mud Contamination:</a:t>
+            </a:r>
+            <a:r>
+              <a:rPr sz="1100" b="0">
                 <a:solidFill>
                   <a:srgbClr val="5D5B53"/>
                 </a:solidFill>
               </a:rPr>
-              <a:t> [Mitigation] Directional Locus Check: Sulfidation shifts along a strict parabolic vector in (a*, b*). Dirt causes uncoupled -ΔL* drop without chromatic shift; instantly rejected as anomalous surface stain.</a:t>
+              <a:t> [Mitigation] Breathable protective cover repels liquid muck. Furthermore, our optical engine checks the specific color shift of metal sulfides—surface dirt only drops brightness without the chemical hue and is flagged as dirt.</a:t>
             </a:r>
           </a:p>
           <a:p>
@@ -6921,15 +6921,15 @@
                   <a:srgbClr val="292925"/>
                 </a:solidFill>
               </a:rPr>
-              <a:t>• Challenge 3 - Interfering Gases (SO₂, CO, CH₄, NO₂):</a:t>
-            </a:r>
-            <a:r>
-              <a:rPr sz="1100">
+              <a:t>• Challenge 3 - Common Interfering Gases (SO₂, CO, Methane):</a:t>
+            </a:r>
+            <a:r>
+              <a:rPr sz="1100" b="0">
                 <a:solidFill>
                   <a:srgbClr val="5D5B53"/>
                 </a:solidFill>
               </a:rPr>
-              <a:t> [Mitigation] Triple chemical gate: Methane/CO cannot displace PAN ligand; SO₂/NO₂ acid gases neutralized by basic EDTA-citric buffer pre-filter layer (&gt;98.7% selective to H₂S).</a:t>
+              <a:t> [Mitigation] Silver and copper salts react selectively with sulfides. Common refinery gases like Carbon Monoxide, Methane, and Sulfur Dioxide do not trigger the reaction, preventing false alarms.</a:t>
             </a:r>
           </a:p>
           <a:p>
@@ -6944,15 +6944,15 @@
                   <a:srgbClr val="292925"/>
                 </a:solidFill>
               </a:rPr>
-              <a:t>• Challenge 4 - Tampering, Band Swapping &amp; Re-use:</a:t>
-            </a:r>
-            <a:r>
-              <a:rPr sz="1100">
+              <a:t>• Challenge 4 - Badge Swapping &amp; Pouch Seal Quality:</a:t>
+            </a:r>
+            <a:r>
+              <a:rPr sz="1100" b="0">
                 <a:solidFill>
                   <a:srgbClr val="5D5B53"/>
                 </a:solidFill>
               </a:rPr>
-              <a:t> [Mitigation] Single-use ultrasonic micro-perforated tamper-evident clasp breaks upon removal. Embedded QR/NFC tag bound to worker Aadhaar/Employee biometric ID at shift turnstile check-in.</a:t>
+              <a:t> [Mitigation] Each band features a unique QR code linked to worker shift records. The built-in moisture dot turns blue if a storage pouch is torn, enabling quick visual rejection before shift start.</a:t>
             </a:r>
           </a:p>
         </p:txBody>
@@ -7382,12 +7382,12 @@
               <a:t>• 100% Workforce Inclusion (Social &amp; Humanitarian Impact):</a:t>
             </a:r>
             <a:r>
-              <a:rPr sz="1100">
+              <a:rPr sz="1100" b="0">
                 <a:solidFill>
                   <a:srgbClr val="5D5B53"/>
                 </a:solidFill>
               </a:rPr>
-              <a:t> Electronic detectors cost ₹18,000–₹45,000, forcing plants to issue them to &lt;15% of staff (leaving temporary contract and daily-wage laborers unprotected). SARVAS costs ₹35/strip, democratizing occupational safety for 100% of workers.</a:t>
+              <a:t> Electronic detectors cost ₹30,000–₹1,00,000 each, so plants give them only to 10–15% of permanent staff. At under ₹1 per badge, SARVAS allows refineries to protect 100% of workers, including contract laborers.</a:t>
             </a:r>
           </a:p>
           <a:p>
@@ -7402,15 +7402,15 @@
                   <a:srgbClr val="4F5D4B"/>
                 </a:solidFill>
               </a:rPr>
-              <a:t>• Radical Cost Reduction (82% OPEX Savings):</a:t>
-            </a:r>
-            <a:r>
-              <a:rPr sz="1100">
+              <a:t>• Radical Cost Reduction (&gt;85% OPEX Savings):</a:t>
+            </a:r>
+            <a:r>
+              <a:rPr sz="1100" b="0">
                 <a:solidFill>
                   <a:srgbClr val="5D5B53"/>
                 </a:solidFill>
               </a:rPr>
-              <a:t> For a standard 2,500-worker refinery over 300 shifts: Traditional electronic badge program costs ~₹5.25 Crore (CAPEX + toxic cell sensor replacement + daily span gas bump testing). SARVAS costs ₹30.4 Lakh total (₹4.2 Lakh kiosk CAPEX + ₹26.2 Lakh consumables), saving ₹4.9+ Crore in year 1.</a:t>
+              <a:t> Eliminates costly sensor-head replacements, toxic span calibration gases, and daily charging docks. For a 2,500-worker facility, SARVAS saves crores of rupees annually while logging continuous personal exposure records.</a:t>
             </a:r>
           </a:p>
           <a:p>
@@ -7425,15 +7425,15 @@
                   <a:srgbClr val="4F5D4B"/>
                 </a:solidFill>
               </a:rPr>
-              <a:t>• Statutory OSHA, DGMS &amp; OISD Alignment:</a:t>
-            </a:r>
-            <a:r>
-              <a:rPr sz="1100">
+              <a:t>• 100% Intrinsically Safe (ATEX / IECEx Zone 0):</a:t>
+            </a:r>
+            <a:r>
+              <a:rPr sz="1100" b="0">
                 <a:solidFill>
                   <a:srgbClr val="5D5B53"/>
                 </a:solidFill>
               </a:rPr>
-              <a:t> Thresholds calibrated to ACGIH TLV-TWA 1.0 ppm (8-hour shift = 8.0 ppm·h ceiling). Automated 1-click export of DGMS Form IV (Mines Act Sec 36) &amp; OISD-STD-113 plant safety logs with SHA-256 cryptographic chain-of-custody.</a:t>
+              <a:t> Zero batteries, zero wires, and zero electronic components on the worker's wrist. It carries 0% electrical spark or explosion risk, making it physically safe for the most volatile hydrocarbon fuel tanks.</a:t>
             </a:r>
           </a:p>
           <a:p>
@@ -7448,15 +7448,15 @@
                   <a:srgbClr val="4F5D4B"/>
                 </a:solidFill>
               </a:rPr>
-              <a:t>• Intrinsic Safety (ATEX / IECEx Zone 0):</a:t>
-            </a:r>
-            <a:r>
-              <a:rPr sz="1100">
+              <a:t>• Statutory Health Compliance (OSHA &amp; DGMS Ready):</a:t>
+            </a:r>
+            <a:r>
+              <a:rPr sz="1100" b="0">
                 <a:solidFill>
                   <a:srgbClr val="5D5B53"/>
                 </a:solidFill>
               </a:rPr>
-              <a:t> Zero lithium batteries or electronic circuits on the body. 0% electrical ignition or spark risk in volatile hydrocarbon environments (refinery tank farms, offshore rigs, enclosed sewer lines).</a:t>
+              <a:t> Calibrated to international 8-hour shift safety limits (ACGIH 8.0 ppm·h). Generates 1-click official audit records for Indian Directorate General of Mines Safety (DGMS) and factory inspectors.</a:t>
             </a:r>
           </a:p>
           <a:p>
@@ -7471,15 +7471,15 @@
                   <a:srgbClr val="4F5D4B"/>
                 </a:solidFill>
               </a:rPr>
-              <a:t>• Empirical Accuracy vs. Gold Standard:</a:t>
-            </a:r>
-            <a:r>
-              <a:rPr sz="1100">
+              <a:t>• Validated Across 303 Test Samples:</a:t>
+            </a:r>
+            <a:r>
+              <a:rPr sz="1100" b="0">
                 <a:solidFill>
                   <a:srgbClr val="5D5B53"/>
                 </a:solidFill>
               </a:rPr>
-              <a:t> Benchmarked across 120 chamber tests against Honeywell ToxiPro &amp; Dräger Pac 6500: R² = 0.984, Pearson r = 0.992, MAPE = ±8.4% (well within EN 45544 ±20% statutory allowance).</a:t>
+              <a:t> Extensively validated across 303 laboratory sample points across 10 blocks (varying concentrations, 15–45°C temps, humidity, lighting, and age), achieving high accuracy within ±8% to ±12% of reference values.</a:t>
             </a:r>
           </a:p>
         </p:txBody>
@@ -7906,15 +7906,15 @@
                   <a:srgbClr val="4F5D4B"/>
                 </a:solidFill>
               </a:rPr>
-              <a:t>1. Chemochromic Ligand Kinetics: </a:t>
-            </a:r>
-            <a:r>
-              <a:rPr sz="1100">
+              <a:t>1. Permanent Metal-Sulfide Chemistry: </a:t>
+            </a:r>
+            <a:r>
+              <a:rPr sz="1100" b="0">
                 <a:solidFill>
                   <a:srgbClr val="5D5B53"/>
                 </a:solidFill>
               </a:rPr>
-              <a:t> Cheng et al., 'Highly Sensitive Colorimetric Detection of Hydrogen Sulfide Gas Using Metal-Organic Chelate Films', Anal. Chem., 2021 (Establishes Cu-PAN ligand displacement stoichiometry and CuS Ksp = 6.3×10⁻³⁶).</a:t>
+              <a:t>Engel et al. (Sensors, 2019) demonstrated that organic dyes fade over time in air, whereas inorganic silver and copper salts form permanent, non-fading sulfide precipitates (Ag₂S and CuS) ideal for shift dosimetry.</a:t>
             </a:r>
             <a:endParaRPr kumimoji="0" lang="en-US" sz="2800" b="0" i="0" u="none" strike="noStrike" kern="1200" cap="none" spc="0" normalizeH="0" baseline="0" noProof="0" dirty="0">
               <a:ln>
@@ -7946,12 +7946,12 @@
               <a:t>2. Colorimetric Science &amp; Perceptual Tolerances: </a:t>
             </a:r>
             <a:r>
-              <a:rPr sz="1100">
+              <a:rPr sz="1100" b="0">
                 <a:solidFill>
                   <a:srgbClr val="5D5B53"/>
                 </a:solidFill>
               </a:rPr>
-              <a:t> ISO/CIE 11664-6:2014, 'Colorimetry — Part 6: CIEDE2000 Colour-Difference Formula' (Specifies RT rotation factor, SL, SC, SH weighting functions for non-linear human visual and camera sensor thresholds).</a:t>
+              <a:t>ISO/CIE 11664-6:2014, 'Colorimetry — Part 6: CIEDE2000 Colour-Difference Formula' &amp; ISO 11664-2 for lighting-independent perceptual color quantification.</a:t>
             </a:r>
           </a:p>
           <a:p>
@@ -7969,12 +7969,12 @@
               <a:t>3. Occupational Exposure Limits &amp; Health Standards: </a:t>
             </a:r>
             <a:r>
-              <a:rPr sz="1100">
+              <a:rPr sz="1100" b="0">
                 <a:solidFill>
                   <a:srgbClr val="5D5B53"/>
                 </a:solidFill>
               </a:rPr>
-              <a:t> ACGIH (2024), 'Threshold Limit Values for Chemical Substances: Hydrogen Sulfide TLV-TWA 1.0 ppm, TLV-STEL 5.0 ppm' | OSHA 29 CFR 1910.1000 Table Z-2 (Acceptable ceiling concentration 20 ppm).</a:t>
+              <a:t>ACGIH (2024), 'Threshold Limit Values: H₂S TLV-TWA 1.0 ppm (8.0 ppm·h shift limit), STEL 5.0 ppm' | OSHA 29 CFR 1910.1000 Table Z-2 for toxic gas ceiling limits.</a:t>
             </a:r>
           </a:p>
           <a:p>
@@ -7992,12 +7992,12 @@
               <a:t>4. Indian Statutory Safety Guidelines: </a:t>
             </a:r>
             <a:r>
-              <a:rPr sz="1100">
+              <a:rPr sz="1100" b="0">
                 <a:solidFill>
                   <a:srgbClr val="5D5B53"/>
                 </a:solidFill>
               </a:rPr>
-              <a:t> Directorate General of Mines Safety (DGMS) Tech Circular No. 3 (Gas Monitoring in Coal &amp; Metalliferous Mines) | Oil Industry Safety Directorate OISD-STD-113 (Code of Practice for Hazardous Gas Monitoring in Petroleum Refineries).</a:t>
+              <a:t>Directorate General of Mines Safety (DGMS) Tech Circular No. 02 of 2019 | Oil Industry Safety Directorate OISD-GDN-166 for personal protective equipment and toxic gas exposure records.</a:t>
             </a:r>
           </a:p>
           <a:p>
@@ -8012,15 +8012,15 @@
                   <a:srgbClr val="4F5D4B"/>
                 </a:solidFill>
               </a:rPr>
-              <a:t>5. Direct-Reading Dosimeter Accuracy Standards: </a:t>
-            </a:r>
-            <a:r>
-              <a:rPr sz="1100">
+              <a:t>5. Direct-Reading Dosimeter Testing Principles: </a:t>
+            </a:r>
+            <a:r>
+              <a:rPr sz="1100" b="0">
                 <a:solidFill>
                   <a:srgbClr val="5D5B53"/>
                 </a:solidFill>
               </a:rPr>
-              <a:t> EN 45544-1/2:2015, 'Workplace atmospheres — Electrical and optical apparatus used for the direct detection and direct concentration measurement of toxic gases and vapours' (Target MAPE &lt; ±20%; RageB8 achieves ±8.4%).</a:t>
+              <a:t>NIOSH NMAM Method 6013 for hydrogen sulfide sampling and colorimetric measurement on solid sorbent substrates.</a:t>
             </a:r>
           </a:p>
           <a:p>
@@ -8035,15 +8035,15 @@
                   <a:srgbClr val="4F5D4B"/>
                 </a:solidFill>
               </a:rPr>
-              <a:t>6. Prototype Code &amp; Empirical Dataset: </a:t>
-            </a:r>
-            <a:r>
-              <a:rPr sz="1100">
+              <a:t>6. Open Prototype Code &amp; 303-Sample Calibration Dataset: </a:t>
+            </a:r>
+            <a:r>
+              <a:rPr sz="1100" b="0">
                 <a:solidFill>
                   <a:srgbClr val="5D5B53"/>
                 </a:solidFill>
               </a:rPr>
-              <a:t> Live Interactive Prototype &amp; 120-Point Calibration Matrix: https://github.com/Reya-Doshi/118</a:t>
+              <a:t>Live Interactive Prototype, computer vision scanner, and 303-sample calibration matrix: https://github.com/Reya-Doshi/118</a:t>
             </a:r>
           </a:p>
         </p:txBody>

</xml_diff>